<commit_message>
feat: add K-Means algorithm overview slide and update total slide count
</commit_message>
<xml_diff>
--- a/KMeans_Presentation.pptx
+++ b/KMeans_Presentation.pptx
@@ -15,6 +15,7 @@
     <p:sldId id="263" r:id="rId14"/>
     <p:sldId id="264" r:id="rId15"/>
     <p:sldId id="265" r:id="rId16"/>
+    <p:sldId id="266" r:id="rId17"/>
   </p:sldIdLst>
   <p:sldSz cx="12191695" cy="6858000" type="screen4x3"/>
   <p:notesSz cx="6858000" cy="9144000"/>
@@ -4682,7 +4683,7 @@
               </a:defRPr>
             </a:pPr>
             <a:r>
-              <a:t>AMD Ryzen 7 7840HS &amp; Radeon 780M Benchmarking Suite | Page 1 of 10</a:t>
+              <a:t>AMD Ryzen 7 7840HS &amp; Radeon 780M Benchmarking Suite | Page 1 of 11</a:t>
             </a:r>
           </a:p>
         </p:txBody>
@@ -4696,6 +4697,176 @@
 </file>
 
 <file path=ppt/slides/slide10.xml><?xml version="1.0" encoding="utf-8"?>
+<p:sld xmlns:a="http://schemas.openxmlformats.org/drawingml/2006/main" xmlns:p="http://schemas.openxmlformats.org/presentationml/2006/main" xmlns:r="http://schemas.openxmlformats.org/officeDocument/2006/relationships">
+  <p:cSld>
+    <p:bg>
+      <p:bgPr>
+        <a:solidFill>
+          <a:srgbClr val="F8FAFC"/>
+        </a:solidFill>
+        <a:effectLst/>
+      </p:bgPr>
+    </p:bg>
+    <p:spTree>
+      <p:nvGrpSpPr>
+        <p:cNvPr id="1" name=""/>
+        <p:cNvGrpSpPr/>
+        <p:nvPr/>
+      </p:nvGrpSpPr>
+      <p:grpSpPr/>
+      <p:sp>
+        <p:nvSpPr>
+          <p:cNvPr id="2" name="TextBox 1"/>
+          <p:cNvSpPr txBox="1"/>
+          <p:nvPr/>
+        </p:nvSpPr>
+        <p:spPr>
+          <a:xfrm>
+            <a:off x="731520" y="365760"/>
+            <a:ext cx="10698480" cy="274320"/>
+          </a:xfrm>
+          <a:prstGeom prst="rect">
+            <a:avLst/>
+          </a:prstGeom>
+          <a:noFill/>
+        </p:spPr>
+        <p:txBody>
+          <a:bodyPr wrap="square" lIns="0" tIns="0" rIns="0" bIns="0">
+            <a:spAutoFit/>
+          </a:bodyPr>
+          <a:lstStyle/>
+          <a:p>
+            <a:pPr>
+              <a:defRPr sz="1200" b="1">
+                <a:solidFill>
+                  <a:srgbClr val="06B6D4"/>
+                </a:solidFill>
+                <a:latin typeface="Calibri"/>
+              </a:defRPr>
+            </a:pPr>
+            <a:r>
+              <a:t>K-MEANS PARALLEL BENCHMARK</a:t>
+            </a:r>
+          </a:p>
+        </p:txBody>
+      </p:sp>
+      <p:sp>
+        <p:nvSpPr>
+          <p:cNvPr id="3" name="TextBox 2"/>
+          <p:cNvSpPr txBox="1"/>
+          <p:nvPr/>
+        </p:nvSpPr>
+        <p:spPr>
+          <a:xfrm>
+            <a:off x="731520" y="594360"/>
+            <a:ext cx="10698480" cy="731520"/>
+          </a:xfrm>
+          <a:prstGeom prst="rect">
+            <a:avLst/>
+          </a:prstGeom>
+          <a:noFill/>
+        </p:spPr>
+        <p:txBody>
+          <a:bodyPr wrap="square" lIns="0" tIns="0" rIns="0" bIns="0">
+            <a:spAutoFit/>
+          </a:bodyPr>
+          <a:lstStyle/>
+          <a:p>
+            <a:pPr>
+              <a:defRPr sz="3200" b="1">
+                <a:solidFill>
+                  <a:srgbClr val="0F172A"/>
+                </a:solidFill>
+                <a:latin typeface="Trebuchet MS"/>
+              </a:defRPr>
+            </a:pPr>
+            <a:r>
+              <a:t>Real-World Datasets: Execution Time &amp; Speedup Curves</a:t>
+            </a:r>
+          </a:p>
+        </p:txBody>
+      </p:sp>
+      <p:graphicFrame>
+        <p:nvGraphicFramePr>
+          <p:cNvPr id="4" name="Chart 3"/>
+          <p:cNvGraphicFramePr>
+            <a:graphicFrameLocks noGrp="1"/>
+          </p:cNvGraphicFramePr>
+          <p:nvPr/>
+        </p:nvGraphicFramePr>
+        <p:xfrm>
+          <a:off x="457200" y="1645920"/>
+          <a:ext cx="5303520" cy="4114800"/>
+        </p:xfrm>
+        <a:graphic>
+          <a:graphicData uri="http://schemas.openxmlformats.org/drawingml/2006/chart">
+            <c:chart xmlns:c="http://schemas.openxmlformats.org/drawingml/2006/chart" r:id="rId2"/>
+          </a:graphicData>
+        </a:graphic>
+      </p:graphicFrame>
+      <p:graphicFrame>
+        <p:nvGraphicFramePr>
+          <p:cNvPr id="5" name="Chart 4"/>
+          <p:cNvGraphicFramePr>
+            <a:graphicFrameLocks noGrp="1"/>
+          </p:cNvGraphicFramePr>
+          <p:nvPr/>
+        </p:nvGraphicFramePr>
+        <p:xfrm>
+          <a:off x="6217920" y="1645920"/>
+          <a:ext cx="5303520" cy="4114800"/>
+        </p:xfrm>
+        <a:graphic>
+          <a:graphicData uri="http://schemas.openxmlformats.org/drawingml/2006/chart">
+            <c:chart xmlns:c="http://schemas.openxmlformats.org/drawingml/2006/chart" r:id="rId3"/>
+          </a:graphicData>
+        </a:graphic>
+      </p:graphicFrame>
+      <p:sp>
+        <p:nvSpPr>
+          <p:cNvPr id="6" name="TextBox 5"/>
+          <p:cNvSpPr txBox="1"/>
+          <p:nvPr/>
+        </p:nvSpPr>
+        <p:spPr>
+          <a:xfrm>
+            <a:off x="731520" y="6400800"/>
+            <a:ext cx="10698480" cy="274320"/>
+          </a:xfrm>
+          <a:prstGeom prst="rect">
+            <a:avLst/>
+          </a:prstGeom>
+          <a:noFill/>
+        </p:spPr>
+        <p:txBody>
+          <a:bodyPr wrap="square" lIns="0" tIns="0" rIns="0" bIns="0">
+            <a:spAutoFit/>
+          </a:bodyPr>
+          <a:lstStyle/>
+          <a:p>
+            <a:pPr>
+              <a:defRPr sz="1100">
+                <a:solidFill>
+                  <a:srgbClr val="64748B"/>
+                </a:solidFill>
+                <a:latin typeface="Calibri"/>
+              </a:defRPr>
+            </a:pPr>
+            <a:r>
+              <a:t>AMD Ryzen 7 7840HS &amp; Radeon 780M Benchmarking Suite | Page 10 of 11</a:t>
+            </a:r>
+          </a:p>
+        </p:txBody>
+      </p:sp>
+    </p:spTree>
+  </p:cSld>
+  <p:clrMapOvr>
+    <a:masterClrMapping/>
+  </p:clrMapOvr>
+</p:sld>
+</file>
+
+<file path=ppt/slides/slide11.xml><?xml version="1.0" encoding="utf-8"?>
 <p:sld xmlns:a="http://schemas.openxmlformats.org/drawingml/2006/main" xmlns:p="http://schemas.openxmlformats.org/presentationml/2006/main" xmlns:r="http://schemas.openxmlformats.org/officeDocument/2006/relationships">
   <p:cSld>
     <p:bg>
@@ -5077,7 +5248,7 @@
               </a:defRPr>
             </a:pPr>
             <a:r>
-              <a:t>AMD Ryzen 7 7840HS &amp; Radeon 780M Benchmarking Suite | Page 10 of 10</a:t>
+              <a:t>AMD Ryzen 7 7840HS &amp; Radeon 780M Benchmarking Suite | Page 11 of 11</a:t>
             </a:r>
           </a:p>
         </p:txBody>
@@ -5091,6 +5262,400 @@
 </file>
 
 <file path=ppt/slides/slide2.xml><?xml version="1.0" encoding="utf-8"?>
+<p:sld xmlns:a="http://schemas.openxmlformats.org/drawingml/2006/main" xmlns:p="http://schemas.openxmlformats.org/presentationml/2006/main" xmlns:r="http://schemas.openxmlformats.org/officeDocument/2006/relationships">
+  <p:cSld>
+    <p:bg>
+      <p:bgPr>
+        <a:solidFill>
+          <a:srgbClr val="F8FAFC"/>
+        </a:solidFill>
+        <a:effectLst/>
+      </p:bgPr>
+    </p:bg>
+    <p:spTree>
+      <p:nvGrpSpPr>
+        <p:cNvPr id="1" name=""/>
+        <p:cNvGrpSpPr/>
+        <p:nvPr/>
+      </p:nvGrpSpPr>
+      <p:grpSpPr/>
+      <p:sp>
+        <p:nvSpPr>
+          <p:cNvPr id="2" name="TextBox 1"/>
+          <p:cNvSpPr txBox="1"/>
+          <p:nvPr/>
+        </p:nvSpPr>
+        <p:spPr>
+          <a:xfrm>
+            <a:off x="731520" y="365760"/>
+            <a:ext cx="10698480" cy="274320"/>
+          </a:xfrm>
+          <a:prstGeom prst="rect">
+            <a:avLst/>
+          </a:prstGeom>
+          <a:noFill/>
+        </p:spPr>
+        <p:txBody>
+          <a:bodyPr wrap="square" lIns="0" tIns="0" rIns="0" bIns="0">
+            <a:spAutoFit/>
+          </a:bodyPr>
+          <a:lstStyle/>
+          <a:p>
+            <a:pPr>
+              <a:defRPr sz="1200" b="1">
+                <a:solidFill>
+                  <a:srgbClr val="06B6D4"/>
+                </a:solidFill>
+                <a:latin typeface="Calibri"/>
+              </a:defRPr>
+            </a:pPr>
+            <a:r>
+              <a:t>K-MEANS PARALLEL BENCHMARK</a:t>
+            </a:r>
+          </a:p>
+        </p:txBody>
+      </p:sp>
+      <p:sp>
+        <p:nvSpPr>
+          <p:cNvPr id="3" name="TextBox 2"/>
+          <p:cNvSpPr txBox="1"/>
+          <p:nvPr/>
+        </p:nvSpPr>
+        <p:spPr>
+          <a:xfrm>
+            <a:off x="731520" y="594360"/>
+            <a:ext cx="10698480" cy="731520"/>
+          </a:xfrm>
+          <a:prstGeom prst="rect">
+            <a:avLst/>
+          </a:prstGeom>
+          <a:noFill/>
+        </p:spPr>
+        <p:txBody>
+          <a:bodyPr wrap="square" lIns="0" tIns="0" rIns="0" bIns="0">
+            <a:spAutoFit/>
+          </a:bodyPr>
+          <a:lstStyle/>
+          <a:p>
+            <a:pPr>
+              <a:defRPr sz="3200" b="1">
+                <a:solidFill>
+                  <a:srgbClr val="0F172A"/>
+                </a:solidFill>
+                <a:latin typeface="Trebuchet MS"/>
+              </a:defRPr>
+            </a:pPr>
+            <a:r>
+              <a:t>Project Theme: K-Means Clustering &amp; Lloyd's Algorithm</a:t>
+            </a:r>
+          </a:p>
+        </p:txBody>
+      </p:sp>
+      <p:sp>
+        <p:nvSpPr>
+          <p:cNvPr id="4" name="Rounded Rectangle 3"/>
+          <p:cNvSpPr/>
+          <p:nvPr/>
+        </p:nvSpPr>
+        <p:spPr>
+          <a:xfrm>
+            <a:off x="731520" y="1645920"/>
+            <a:ext cx="5120640" cy="4480560"/>
+          </a:xfrm>
+          <a:prstGeom prst="roundRect">
+            <a:avLst/>
+          </a:prstGeom>
+          <a:solidFill>
+            <a:srgbClr val="FFFFFF"/>
+          </a:solidFill>
+          <a:ln>
+            <a:solidFill>
+              <a:srgbClr val="E2E8F0"/>
+            </a:solidFill>
+          </a:ln>
+        </p:spPr>
+        <p:style>
+          <a:lnRef idx="1">
+            <a:schemeClr val="accent1"/>
+          </a:lnRef>
+          <a:fillRef idx="3">
+            <a:schemeClr val="accent1"/>
+          </a:fillRef>
+          <a:effectRef idx="2">
+            <a:schemeClr val="accent1"/>
+          </a:effectRef>
+          <a:fontRef idx="minor">
+            <a:schemeClr val="lt1"/>
+          </a:fontRef>
+        </p:style>
+        <p:txBody>
+          <a:bodyPr rtlCol="0" anchor="ctr" wrap="square" lIns="274320" rIns="274320" tIns="274320" bIns="274320"/>
+          <a:lstStyle/>
+          <a:p>
+            <a:pPr algn="ctr">
+              <a:spcAft>
+                <a:spcPts val="800"/>
+              </a:spcAft>
+              <a:defRPr sz="2200" b="1">
+                <a:solidFill>
+                  <a:srgbClr val="1E293B"/>
+                </a:solidFill>
+                <a:latin typeface="Trebuchet MS"/>
+              </a:defRPr>
+            </a:pPr>
+            <a:r>
+              <a:t>Lloyd's Algorithm (Standard K-Means)</a:t>
+            </a:r>
+          </a:p>
+          <a:p>
+            <a:pPr>
+              <a:spcAft>
+                <a:spcPts val="500"/>
+              </a:spcAft>
+              <a:defRPr sz="1300" b="0">
+                <a:solidFill>
+                  <a:srgbClr val="0F172A"/>
+                </a:solidFill>
+                <a:latin typeface="Calibri"/>
+              </a:defRPr>
+            </a:pPr>
+            <a:r>
+              <a:t>1. Initialize: Pick K random points as the initial centroids (Forgy method).</a:t>
+            </a:r>
+          </a:p>
+          <a:p>
+            <a:pPr>
+              <a:spcAft>
+                <a:spcPts val="500"/>
+              </a:spcAft>
+              <a:defRPr sz="1300" b="1">
+                <a:solidFill>
+                  <a:srgbClr val="06B6D4"/>
+                </a:solidFill>
+                <a:latin typeface="Calibri"/>
+              </a:defRPr>
+            </a:pPr>
+            <a:r>
+              <a:t>2. Assign (Expectation): Calculate the distance from every point to every centroid. Assign each point to its nearest centroid to form Voronoi partitions.</a:t>
+            </a:r>
+          </a:p>
+          <a:p>
+            <a:pPr>
+              <a:spcAft>
+                <a:spcPts val="500"/>
+              </a:spcAft>
+              <a:defRPr sz="1300" b="0">
+                <a:solidFill>
+                  <a:srgbClr val="0F172A"/>
+                </a:solidFill>
+                <a:latin typeface="Calibri"/>
+              </a:defRPr>
+            </a:pPr>
+            <a:r>
+              <a:t>3. Update (Maximization): Recompute the position of each centroid by calculating the arithmetic mean of all points assigned to it.</a:t>
+            </a:r>
+          </a:p>
+          <a:p>
+            <a:pPr>
+              <a:spcAft>
+                <a:spcPts val="500"/>
+              </a:spcAft>
+              <a:defRPr sz="1300" b="0">
+                <a:solidFill>
+                  <a:srgbClr val="0F172A"/>
+                </a:solidFill>
+                <a:latin typeface="Calibri"/>
+              </a:defRPr>
+            </a:pPr>
+            <a:r>
+              <a:t>4. Repeat: Loop through Steps 2 and 3 until no points change their cluster assignments (convergence guaranteed).</a:t>
+            </a:r>
+          </a:p>
+        </p:txBody>
+      </p:sp>
+      <p:sp>
+        <p:nvSpPr>
+          <p:cNvPr id="5" name="Rounded Rectangle 4"/>
+          <p:cNvSpPr/>
+          <p:nvPr/>
+        </p:nvSpPr>
+        <p:spPr>
+          <a:xfrm>
+            <a:off x="6309360" y="1645920"/>
+            <a:ext cx="5120640" cy="4480560"/>
+          </a:xfrm>
+          <a:prstGeom prst="roundRect">
+            <a:avLst/>
+          </a:prstGeom>
+          <a:solidFill>
+            <a:srgbClr val="FFFFFF"/>
+          </a:solidFill>
+          <a:ln>
+            <a:solidFill>
+              <a:srgbClr val="E2E8F0"/>
+            </a:solidFill>
+          </a:ln>
+        </p:spPr>
+        <p:style>
+          <a:lnRef idx="1">
+            <a:schemeClr val="accent1"/>
+          </a:lnRef>
+          <a:fillRef idx="3">
+            <a:schemeClr val="accent1"/>
+          </a:fillRef>
+          <a:effectRef idx="2">
+            <a:schemeClr val="accent1"/>
+          </a:effectRef>
+          <a:fontRef idx="minor">
+            <a:schemeClr val="lt1"/>
+          </a:fontRef>
+        </p:style>
+        <p:txBody>
+          <a:bodyPr rtlCol="0" anchor="ctr" wrap="square" lIns="274320" rIns="274320" tIns="274320" bIns="274320"/>
+          <a:lstStyle/>
+          <a:p>
+            <a:pPr algn="ctr">
+              <a:spcAft>
+                <a:spcPts val="800"/>
+              </a:spcAft>
+              <a:defRPr sz="2200" b="1">
+                <a:solidFill>
+                  <a:srgbClr val="1E293B"/>
+                </a:solidFill>
+                <a:latin typeface="Trebuchet MS"/>
+              </a:defRPr>
+            </a:pPr>
+            <a:r>
+              <a:t>Complexity &amp; The Parallelization Goal</a:t>
+            </a:r>
+          </a:p>
+          <a:p>
+            <a:pPr>
+              <a:spcAft>
+                <a:spcPts val="800"/>
+              </a:spcAft>
+              <a:defRPr sz="1600" b="1">
+                <a:solidFill>
+                  <a:srgbClr val="EF4444"/>
+                </a:solidFill>
+                <a:latin typeface="Trebuchet MS"/>
+              </a:defRPr>
+            </a:pPr>
+            <a:r>
+              <a:t>Sequential Complexity: O(N × K × D × I)</a:t>
+            </a:r>
+          </a:p>
+          <a:p>
+            <a:pPr>
+              <a:spcAft>
+                <a:spcPts val="400"/>
+              </a:spcAft>
+              <a:defRPr sz="1250">
+                <a:solidFill>
+                  <a:srgbClr val="0F172A"/>
+                </a:solidFill>
+                <a:latin typeface="Calibri"/>
+              </a:defRPr>
+            </a:pPr>
+            <a:r>
+              <a:t>• N = Points, K = Clusters, D = Dimensions, I = Iterations.</a:t>
+            </a:r>
+          </a:p>
+          <a:p>
+            <a:pPr>
+              <a:spcAft>
+                <a:spcPts val="400"/>
+              </a:spcAft>
+              <a:defRPr sz="1250">
+                <a:solidFill>
+                  <a:srgbClr val="0F172A"/>
+                </a:solidFill>
+                <a:latin typeface="Calibri"/>
+              </a:defRPr>
+            </a:pPr>
+            <a:r>
+              <a:t>• The Bottleneck: The Assignment phase (Step 2) requires N × K distance calculations per iteration. For large datasets, this nested loop takes up &gt;95% of execution time.</a:t>
+            </a:r>
+          </a:p>
+          <a:p>
+            <a:pPr>
+              <a:spcAft>
+                <a:spcPts val="400"/>
+              </a:spcAft>
+              <a:defRPr sz="1250">
+                <a:solidFill>
+                  <a:srgbClr val="0F172A"/>
+                </a:solidFill>
+                <a:latin typeface="Calibri"/>
+              </a:defRPr>
+            </a:pPr>
+            <a:r>
+              <a:t>• The Parallel Opportunity: Step 2 is 'Embarrassingly Parallel'. Finding the nearest centroid for point A is completely independent of finding the nearest centroid for point B.</a:t>
+            </a:r>
+          </a:p>
+          <a:p>
+            <a:pPr>
+              <a:spcAft>
+                <a:spcPts val="400"/>
+              </a:spcAft>
+              <a:defRPr sz="1250">
+                <a:solidFill>
+                  <a:srgbClr val="0F172A"/>
+                </a:solidFill>
+                <a:latin typeface="Calibri"/>
+              </a:defRPr>
+            </a:pPr>
+            <a:r>
+              <a:t>• Project Goal: Exploit this independence across GPU threads (HIP), distributed memory architectures (MPI), and SIMD vectorization (scikit-learn) to drastically reduce execution time.</a:t>
+            </a:r>
+          </a:p>
+        </p:txBody>
+      </p:sp>
+      <p:sp>
+        <p:nvSpPr>
+          <p:cNvPr id="6" name="TextBox 5"/>
+          <p:cNvSpPr txBox="1"/>
+          <p:nvPr/>
+        </p:nvSpPr>
+        <p:spPr>
+          <a:xfrm>
+            <a:off x="731520" y="6400800"/>
+            <a:ext cx="10698480" cy="274320"/>
+          </a:xfrm>
+          <a:prstGeom prst="rect">
+            <a:avLst/>
+          </a:prstGeom>
+          <a:noFill/>
+        </p:spPr>
+        <p:txBody>
+          <a:bodyPr wrap="square" lIns="0" tIns="0" rIns="0" bIns="0">
+            <a:spAutoFit/>
+          </a:bodyPr>
+          <a:lstStyle/>
+          <a:p>
+            <a:pPr>
+              <a:defRPr sz="1100">
+                <a:solidFill>
+                  <a:srgbClr val="64748B"/>
+                </a:solidFill>
+                <a:latin typeface="Calibri"/>
+              </a:defRPr>
+            </a:pPr>
+            <a:r>
+              <a:t>AMD Ryzen 7 7840HS &amp; Radeon 780M Benchmarking Suite | Page 2 of 11</a:t>
+            </a:r>
+          </a:p>
+        </p:txBody>
+      </p:sp>
+    </p:spTree>
+  </p:cSld>
+  <p:clrMapOvr>
+    <a:masterClrMapping/>
+  </p:clrMapOvr>
+</p:sld>
+</file>
+
+<file path=ppt/slides/slide3.xml><?xml version="1.0" encoding="utf-8"?>
 <p:sld xmlns:a="http://schemas.openxmlformats.org/drawingml/2006/main" xmlns:p="http://schemas.openxmlformats.org/presentationml/2006/main" xmlns:r="http://schemas.openxmlformats.org/officeDocument/2006/relationships">
   <p:cSld>
     <p:bg>
@@ -5487,7 +6052,7 @@
               </a:defRPr>
             </a:pPr>
             <a:r>
-              <a:t>AMD Ryzen 7 7840HS &amp; Radeon 780M Benchmarking Suite | Page 2 of 10</a:t>
+              <a:t>AMD Ryzen 7 7840HS &amp; Radeon 780M Benchmarking Suite | Page 3 of 11</a:t>
             </a:r>
           </a:p>
         </p:txBody>
@@ -5500,7 +6065,7 @@
 </p:sld>
 </file>
 
-<file path=ppt/slides/slide3.xml><?xml version="1.0" encoding="utf-8"?>
+<file path=ppt/slides/slide4.xml><?xml version="1.0" encoding="utf-8"?>
 <p:sld xmlns:a="http://schemas.openxmlformats.org/drawingml/2006/main" xmlns:p="http://schemas.openxmlformats.org/presentationml/2006/main" xmlns:r="http://schemas.openxmlformats.org/officeDocument/2006/relationships">
   <p:cSld>
     <p:bg>
@@ -5957,7 +6522,7 @@
               </a:defRPr>
             </a:pPr>
             <a:r>
-              <a:t>AMD Ryzen 7 7840HS &amp; Radeon 780M Benchmarking Suite | Page 3 of 10</a:t>
+              <a:t>AMD Ryzen 7 7840HS &amp; Radeon 780M Benchmarking Suite | Page 4 of 11</a:t>
             </a:r>
           </a:p>
         </p:txBody>
@@ -5970,7 +6535,7 @@
 </p:sld>
 </file>
 
-<file path=ppt/slides/slide4.xml><?xml version="1.0" encoding="utf-8"?>
+<file path=ppt/slides/slide5.xml><?xml version="1.0" encoding="utf-8"?>
 <p:sld xmlns:a="http://schemas.openxmlformats.org/drawingml/2006/main" xmlns:p="http://schemas.openxmlformats.org/presentationml/2006/main" xmlns:r="http://schemas.openxmlformats.org/officeDocument/2006/relationships">
   <p:cSld>
     <p:bg>
@@ -6388,7 +6953,7 @@
               </a:defRPr>
             </a:pPr>
             <a:r>
-              <a:t>AMD Ryzen 7 7840HS &amp; Radeon 780M Benchmarking Suite | Page 4 of 10</a:t>
+              <a:t>AMD Ryzen 7 7840HS &amp; Radeon 780M Benchmarking Suite | Page 5 of 11</a:t>
             </a:r>
           </a:p>
         </p:txBody>
@@ -6401,7 +6966,7 @@
 </p:sld>
 </file>
 
-<file path=ppt/slides/slide5.xml><?xml version="1.0" encoding="utf-8"?>
+<file path=ppt/slides/slide6.xml><?xml version="1.0" encoding="utf-8"?>
 <p:sld xmlns:a="http://schemas.openxmlformats.org/drawingml/2006/main" xmlns:p="http://schemas.openxmlformats.org/presentationml/2006/main" xmlns:r="http://schemas.openxmlformats.org/officeDocument/2006/relationships">
   <p:cSld>
     <p:bg>
@@ -6664,7 +7229,7 @@
               </a:defRPr>
             </a:pPr>
             <a:r>
-              <a:t>AMD Ryzen 7 7840HS &amp; Radeon 780M Benchmarking Suite | Page 5 of 10</a:t>
+              <a:t>AMD Ryzen 7 7840HS &amp; Radeon 780M Benchmarking Suite | Page 6 of 11</a:t>
             </a:r>
           </a:p>
         </p:txBody>
@@ -6677,7 +7242,7 @@
 </p:sld>
 </file>
 
-<file path=ppt/slides/slide6.xml><?xml version="1.0" encoding="utf-8"?>
+<file path=ppt/slides/slide7.xml><?xml version="1.0" encoding="utf-8"?>
 <p:sld xmlns:a="http://schemas.openxmlformats.org/drawingml/2006/main" xmlns:p="http://schemas.openxmlformats.org/presentationml/2006/main" xmlns:r="http://schemas.openxmlformats.org/officeDocument/2006/relationships">
   <p:cSld>
     <p:bg>
@@ -8100,7 +8665,7 @@
               </a:defRPr>
             </a:pPr>
             <a:r>
-              <a:t>AMD Ryzen 7 7840HS &amp; Radeon 780M Benchmarking Suite | Page 6 of 10</a:t>
+              <a:t>AMD Ryzen 7 7840HS &amp; Radeon 780M Benchmarking Suite | Page 7 of 11</a:t>
             </a:r>
           </a:p>
         </p:txBody>
@@ -8113,7 +8678,7 @@
 </p:sld>
 </file>
 
-<file path=ppt/slides/slide7.xml><?xml version="1.0" encoding="utf-8"?>
+<file path=ppt/slides/slide8.xml><?xml version="1.0" encoding="utf-8"?>
 <p:sld xmlns:a="http://schemas.openxmlformats.org/drawingml/2006/main" xmlns:p="http://schemas.openxmlformats.org/presentationml/2006/main" xmlns:r="http://schemas.openxmlformats.org/officeDocument/2006/relationships">
   <p:cSld>
     <p:bg>
@@ -8270,7 +8835,7 @@
               </a:defRPr>
             </a:pPr>
             <a:r>
-              <a:t>AMD Ryzen 7 7840HS &amp; Radeon 780M Benchmarking Suite | Page 7 of 10</a:t>
+              <a:t>AMD Ryzen 7 7840HS &amp; Radeon 780M Benchmarking Suite | Page 8 of 11</a:t>
             </a:r>
           </a:p>
         </p:txBody>
@@ -8283,7 +8848,7 @@
 </p:sld>
 </file>
 
-<file path=ppt/slides/slide8.xml><?xml version="1.0" encoding="utf-8"?>
+<file path=ppt/slides/slide9.xml><?xml version="1.0" encoding="utf-8"?>
 <p:sld xmlns:a="http://schemas.openxmlformats.org/drawingml/2006/main" xmlns:p="http://schemas.openxmlformats.org/presentationml/2006/main" xmlns:r="http://schemas.openxmlformats.org/officeDocument/2006/relationships">
   <p:cSld>
     <p:bg>
@@ -9706,177 +10271,7 @@
               </a:defRPr>
             </a:pPr>
             <a:r>
-              <a:t>AMD Ryzen 7 7840HS &amp; Radeon 780M Benchmarking Suite | Page 8 of 10</a:t>
-            </a:r>
-          </a:p>
-        </p:txBody>
-      </p:sp>
-    </p:spTree>
-  </p:cSld>
-  <p:clrMapOvr>
-    <a:masterClrMapping/>
-  </p:clrMapOvr>
-</p:sld>
-</file>
-
-<file path=ppt/slides/slide9.xml><?xml version="1.0" encoding="utf-8"?>
-<p:sld xmlns:a="http://schemas.openxmlformats.org/drawingml/2006/main" xmlns:p="http://schemas.openxmlformats.org/presentationml/2006/main" xmlns:r="http://schemas.openxmlformats.org/officeDocument/2006/relationships">
-  <p:cSld>
-    <p:bg>
-      <p:bgPr>
-        <a:solidFill>
-          <a:srgbClr val="F8FAFC"/>
-        </a:solidFill>
-        <a:effectLst/>
-      </p:bgPr>
-    </p:bg>
-    <p:spTree>
-      <p:nvGrpSpPr>
-        <p:cNvPr id="1" name=""/>
-        <p:cNvGrpSpPr/>
-        <p:nvPr/>
-      </p:nvGrpSpPr>
-      <p:grpSpPr/>
-      <p:sp>
-        <p:nvSpPr>
-          <p:cNvPr id="2" name="TextBox 1"/>
-          <p:cNvSpPr txBox="1"/>
-          <p:nvPr/>
-        </p:nvSpPr>
-        <p:spPr>
-          <a:xfrm>
-            <a:off x="731520" y="365760"/>
-            <a:ext cx="10698480" cy="274320"/>
-          </a:xfrm>
-          <a:prstGeom prst="rect">
-            <a:avLst/>
-          </a:prstGeom>
-          <a:noFill/>
-        </p:spPr>
-        <p:txBody>
-          <a:bodyPr wrap="square" lIns="0" tIns="0" rIns="0" bIns="0">
-            <a:spAutoFit/>
-          </a:bodyPr>
-          <a:lstStyle/>
-          <a:p>
-            <a:pPr>
-              <a:defRPr sz="1200" b="1">
-                <a:solidFill>
-                  <a:srgbClr val="06B6D4"/>
-                </a:solidFill>
-                <a:latin typeface="Calibri"/>
-              </a:defRPr>
-            </a:pPr>
-            <a:r>
-              <a:t>K-MEANS PARALLEL BENCHMARK</a:t>
-            </a:r>
-          </a:p>
-        </p:txBody>
-      </p:sp>
-      <p:sp>
-        <p:nvSpPr>
-          <p:cNvPr id="3" name="TextBox 2"/>
-          <p:cNvSpPr txBox="1"/>
-          <p:nvPr/>
-        </p:nvSpPr>
-        <p:spPr>
-          <a:xfrm>
-            <a:off x="731520" y="594360"/>
-            <a:ext cx="10698480" cy="731520"/>
-          </a:xfrm>
-          <a:prstGeom prst="rect">
-            <a:avLst/>
-          </a:prstGeom>
-          <a:noFill/>
-        </p:spPr>
-        <p:txBody>
-          <a:bodyPr wrap="square" lIns="0" tIns="0" rIns="0" bIns="0">
-            <a:spAutoFit/>
-          </a:bodyPr>
-          <a:lstStyle/>
-          <a:p>
-            <a:pPr>
-              <a:defRPr sz="3200" b="1">
-                <a:solidFill>
-                  <a:srgbClr val="0F172A"/>
-                </a:solidFill>
-                <a:latin typeface="Trebuchet MS"/>
-              </a:defRPr>
-            </a:pPr>
-            <a:r>
-              <a:t>Real-World Datasets: Execution Time &amp; Speedup Curves</a:t>
-            </a:r>
-          </a:p>
-        </p:txBody>
-      </p:sp>
-      <p:graphicFrame>
-        <p:nvGraphicFramePr>
-          <p:cNvPr id="4" name="Chart 3"/>
-          <p:cNvGraphicFramePr>
-            <a:graphicFrameLocks noGrp="1"/>
-          </p:cNvGraphicFramePr>
-          <p:nvPr/>
-        </p:nvGraphicFramePr>
-        <p:xfrm>
-          <a:off x="457200" y="1645920"/>
-          <a:ext cx="5303520" cy="4114800"/>
-        </p:xfrm>
-        <a:graphic>
-          <a:graphicData uri="http://schemas.openxmlformats.org/drawingml/2006/chart">
-            <c:chart xmlns:c="http://schemas.openxmlformats.org/drawingml/2006/chart" r:id="rId2"/>
-          </a:graphicData>
-        </a:graphic>
-      </p:graphicFrame>
-      <p:graphicFrame>
-        <p:nvGraphicFramePr>
-          <p:cNvPr id="5" name="Chart 4"/>
-          <p:cNvGraphicFramePr>
-            <a:graphicFrameLocks noGrp="1"/>
-          </p:cNvGraphicFramePr>
-          <p:nvPr/>
-        </p:nvGraphicFramePr>
-        <p:xfrm>
-          <a:off x="6217920" y="1645920"/>
-          <a:ext cx="5303520" cy="4114800"/>
-        </p:xfrm>
-        <a:graphic>
-          <a:graphicData uri="http://schemas.openxmlformats.org/drawingml/2006/chart">
-            <c:chart xmlns:c="http://schemas.openxmlformats.org/drawingml/2006/chart" r:id="rId3"/>
-          </a:graphicData>
-        </a:graphic>
-      </p:graphicFrame>
-      <p:sp>
-        <p:nvSpPr>
-          <p:cNvPr id="6" name="TextBox 5"/>
-          <p:cNvSpPr txBox="1"/>
-          <p:nvPr/>
-        </p:nvSpPr>
-        <p:spPr>
-          <a:xfrm>
-            <a:off x="731520" y="6400800"/>
-            <a:ext cx="10698480" cy="274320"/>
-          </a:xfrm>
-          <a:prstGeom prst="rect">
-            <a:avLst/>
-          </a:prstGeom>
-          <a:noFill/>
-        </p:spPr>
-        <p:txBody>
-          <a:bodyPr wrap="square" lIns="0" tIns="0" rIns="0" bIns="0">
-            <a:spAutoFit/>
-          </a:bodyPr>
-          <a:lstStyle/>
-          <a:p>
-            <a:pPr>
-              <a:defRPr sz="1100">
-                <a:solidFill>
-                  <a:srgbClr val="64748B"/>
-                </a:solidFill>
-                <a:latin typeface="Calibri"/>
-              </a:defRPr>
-            </a:pPr>
-            <a:r>
-              <a:t>AMD Ryzen 7 7840HS &amp; Radeon 780M Benchmarking Suite | Page 9 of 10</a:t>
+              <a:t>AMD Ryzen 7 7840HS &amp; Radeon 780M Benchmarking Suite | Page 9 of 11</a:t>
             </a:r>
           </a:p>
         </p:txBody>

</xml_diff>

<commit_message>
feat: add RAPIDS cuML cloud acceleration slide and update total page count
</commit_message>
<xml_diff>
--- a/KMeans_Presentation.pptx
+++ b/KMeans_Presentation.pptx
@@ -16,6 +16,7 @@
     <p:sldId id="264" r:id="rId15"/>
     <p:sldId id="265" r:id="rId16"/>
     <p:sldId id="266" r:id="rId17"/>
+    <p:sldId id="267" r:id="rId18"/>
   </p:sldIdLst>
   <p:sldSz cx="12191695" cy="6858000" type="screen4x3"/>
   <p:notesSz cx="6858000" cy="9144000"/>
@@ -4683,7 +4684,7 @@
               </a:defRPr>
             </a:pPr>
             <a:r>
-              <a:t>AMD Ryzen 7 7840HS &amp; Radeon 780M Benchmarking Suite | Page 1 of 11</a:t>
+              <a:t>AMD Ryzen 7 7840HS &amp; Radeon 780M Benchmarking Suite | Page 1 of 12</a:t>
             </a:r>
           </a:p>
         </p:txBody>
@@ -4853,7 +4854,7 @@
               </a:defRPr>
             </a:pPr>
             <a:r>
-              <a:t>AMD Ryzen 7 7840HS &amp; Radeon 780M Benchmarking Suite | Page 10 of 11</a:t>
+              <a:t>AMD Ryzen 7 7840HS &amp; Radeon 780M Benchmarking Suite | Page 10 of 12</a:t>
             </a:r>
           </a:p>
         </p:txBody>
@@ -4867,6 +4868,448 @@
 </file>
 
 <file path=ppt/slides/slide11.xml><?xml version="1.0" encoding="utf-8"?>
+<p:sld xmlns:a="http://schemas.openxmlformats.org/drawingml/2006/main" xmlns:p="http://schemas.openxmlformats.org/presentationml/2006/main" xmlns:r="http://schemas.openxmlformats.org/officeDocument/2006/relationships">
+  <p:cSld>
+    <p:bg>
+      <p:bgPr>
+        <a:solidFill>
+          <a:srgbClr val="F8FAFC"/>
+        </a:solidFill>
+        <a:effectLst/>
+      </p:bgPr>
+    </p:bg>
+    <p:spTree>
+      <p:nvGrpSpPr>
+        <p:cNvPr id="1" name=""/>
+        <p:cNvGrpSpPr/>
+        <p:nvPr/>
+      </p:nvGrpSpPr>
+      <p:grpSpPr/>
+      <p:sp>
+        <p:nvSpPr>
+          <p:cNvPr id="2" name="TextBox 1"/>
+          <p:cNvSpPr txBox="1"/>
+          <p:nvPr/>
+        </p:nvSpPr>
+        <p:spPr>
+          <a:xfrm>
+            <a:off x="731520" y="365760"/>
+            <a:ext cx="10698480" cy="274320"/>
+          </a:xfrm>
+          <a:prstGeom prst="rect">
+            <a:avLst/>
+          </a:prstGeom>
+          <a:noFill/>
+        </p:spPr>
+        <p:txBody>
+          <a:bodyPr wrap="square" lIns="0" tIns="0" rIns="0" bIns="0">
+            <a:spAutoFit/>
+          </a:bodyPr>
+          <a:lstStyle/>
+          <a:p>
+            <a:pPr>
+              <a:defRPr sz="1200" b="1">
+                <a:solidFill>
+                  <a:srgbClr val="06B6D4"/>
+                </a:solidFill>
+                <a:latin typeface="Calibri"/>
+              </a:defRPr>
+            </a:pPr>
+            <a:r>
+              <a:t>K-MEANS PARALLEL BENCHMARK</a:t>
+            </a:r>
+          </a:p>
+        </p:txBody>
+      </p:sp>
+      <p:sp>
+        <p:nvSpPr>
+          <p:cNvPr id="3" name="TextBox 2"/>
+          <p:cNvSpPr txBox="1"/>
+          <p:nvPr/>
+        </p:nvSpPr>
+        <p:spPr>
+          <a:xfrm>
+            <a:off x="731520" y="594360"/>
+            <a:ext cx="10698480" cy="731520"/>
+          </a:xfrm>
+          <a:prstGeom prst="rect">
+            <a:avLst/>
+          </a:prstGeom>
+          <a:noFill/>
+        </p:spPr>
+        <p:txBody>
+          <a:bodyPr wrap="square" lIns="0" tIns="0" rIns="0" bIns="0">
+            <a:spAutoFit/>
+          </a:bodyPr>
+          <a:lstStyle/>
+          <a:p>
+            <a:pPr>
+              <a:defRPr sz="3200" b="1">
+                <a:solidFill>
+                  <a:srgbClr val="0F172A"/>
+                </a:solidFill>
+                <a:latin typeface="Trebuchet MS"/>
+              </a:defRPr>
+            </a:pPr>
+            <a:r>
+              <a:t>Cloud Acceleration Requirement: RAPIDS cuML (k-Nearest Neighbors)</a:t>
+            </a:r>
+          </a:p>
+        </p:txBody>
+      </p:sp>
+      <p:sp>
+        <p:nvSpPr>
+          <p:cNvPr id="4" name="Rounded Rectangle 3"/>
+          <p:cNvSpPr/>
+          <p:nvPr/>
+        </p:nvSpPr>
+        <p:spPr>
+          <a:xfrm>
+            <a:off x="731520" y="1645920"/>
+            <a:ext cx="5120640" cy="4114800"/>
+          </a:xfrm>
+          <a:prstGeom prst="roundRect">
+            <a:avLst/>
+          </a:prstGeom>
+          <a:solidFill>
+            <a:srgbClr val="FFFFFF"/>
+          </a:solidFill>
+          <a:ln>
+            <a:solidFill>
+              <a:srgbClr val="E2E8F0"/>
+            </a:solidFill>
+          </a:ln>
+        </p:spPr>
+        <p:style>
+          <a:lnRef idx="1">
+            <a:schemeClr val="accent1"/>
+          </a:lnRef>
+          <a:fillRef idx="3">
+            <a:schemeClr val="accent1"/>
+          </a:fillRef>
+          <a:effectRef idx="2">
+            <a:schemeClr val="accent1"/>
+          </a:effectRef>
+          <a:fontRef idx="minor">
+            <a:schemeClr val="lt1"/>
+          </a:fontRef>
+        </p:style>
+        <p:txBody>
+          <a:bodyPr rtlCol="0" anchor="ctr" wrap="square" lIns="274320" rIns="274320" tIns="274320" bIns="274320"/>
+          <a:lstStyle/>
+          <a:p>
+            <a:pPr algn="ctr">
+              <a:spcAft>
+                <a:spcPts val="1200"/>
+              </a:spcAft>
+              <a:defRPr sz="2400" b="1">
+                <a:solidFill>
+                  <a:srgbClr val="1E293B"/>
+                </a:solidFill>
+                <a:latin typeface="Trebuchet MS"/>
+              </a:defRPr>
+            </a:pPr>
+            <a:r>
+              <a:t>NVIDIA RAPIDS cuML (Google Colab T4)</a:t>
+            </a:r>
+          </a:p>
+          <a:p>
+            <a:pPr>
+              <a:spcAft>
+                <a:spcPts val="1200"/>
+              </a:spcAft>
+              <a:defRPr sz="1400">
+                <a:solidFill>
+                  <a:srgbClr val="0F172A"/>
+                </a:solidFill>
+                <a:latin typeface="Calibri"/>
+              </a:defRPr>
+            </a:pPr>
+            <a:r>
+              <a:t>Executed via Google Colab on an NVIDIA T4 GPU due to strict CUDA requirements. Uses cuBLAS GEMM and Thrust radix-select for distance calculations.</a:t>
+            </a:r>
+          </a:p>
+          <a:p>
+            <a:pPr>
+              <a:spcAft>
+                <a:spcPts val="800"/>
+              </a:spcAft>
+              <a:defRPr sz="1800" b="1">
+                <a:solidFill>
+                  <a:srgbClr val="EF4444"/>
+                </a:solidFill>
+                <a:latin typeface="Trebuchet MS"/>
+              </a:defRPr>
+            </a:pPr>
+            <a:r>
+              <a:t>The k-NN Self-Join Complexity</a:t>
+            </a:r>
+          </a:p>
+          <a:p>
+            <a:pPr>
+              <a:spcAft>
+                <a:spcPts val="600"/>
+              </a:spcAft>
+              <a:defRPr sz="1400">
+                <a:solidFill>
+                  <a:srgbClr val="0F172A"/>
+                </a:solidFill>
+                <a:latin typeface="Calibri"/>
+              </a:defRPr>
+            </a:pPr>
+            <a:r>
+              <a:t>• K-Means (O(N×K)): Distances from N points to K centroids.</a:t>
+            </a:r>
+          </a:p>
+          <a:p>
+            <a:pPr>
+              <a:spcAft>
+                <a:spcPts val="600"/>
+              </a:spcAft>
+              <a:defRPr sz="1400">
+                <a:solidFill>
+                  <a:srgbClr val="0F172A"/>
+                </a:solidFill>
+                <a:latin typeface="Calibri"/>
+              </a:defRPr>
+            </a:pPr>
+            <a:r>
+              <a:t>• k-NN (O(N²)): The required test script computed the nearest neighbors of the dataset AGAINST ITSELF.</a:t>
+            </a:r>
+          </a:p>
+          <a:p>
+            <a:pPr>
+              <a:spcAft>
+                <a:spcPts val="600"/>
+              </a:spcAft>
+              <a:defRPr sz="1400">
+                <a:solidFill>
+                  <a:srgbClr val="0F172A"/>
+                </a:solidFill>
+                <a:latin typeface="Calibri"/>
+              </a:defRPr>
+            </a:pPr>
+            <a:r>
+              <a:t>• This means computing a massive N×N distance matrix!</a:t>
+            </a:r>
+          </a:p>
+        </p:txBody>
+      </p:sp>
+      <p:sp>
+        <p:nvSpPr>
+          <p:cNvPr id="5" name="Rounded Rectangle 4"/>
+          <p:cNvSpPr/>
+          <p:nvPr/>
+        </p:nvSpPr>
+        <p:spPr>
+          <a:xfrm>
+            <a:off x="6309360" y="1645920"/>
+            <a:ext cx="5120640" cy="4114800"/>
+          </a:xfrm>
+          <a:prstGeom prst="roundRect">
+            <a:avLst/>
+          </a:prstGeom>
+          <a:solidFill>
+            <a:srgbClr val="FFFFFF"/>
+          </a:solidFill>
+          <a:ln>
+            <a:solidFill>
+              <a:srgbClr val="E2E8F0"/>
+            </a:solidFill>
+          </a:ln>
+        </p:spPr>
+        <p:style>
+          <a:lnRef idx="1">
+            <a:schemeClr val="accent1"/>
+          </a:lnRef>
+          <a:fillRef idx="3">
+            <a:schemeClr val="accent1"/>
+          </a:fillRef>
+          <a:effectRef idx="2">
+            <a:schemeClr val="accent1"/>
+          </a:effectRef>
+          <a:fontRef idx="minor">
+            <a:schemeClr val="lt1"/>
+          </a:fontRef>
+        </p:style>
+        <p:txBody>
+          <a:bodyPr rtlCol="0" anchor="ctr" wrap="square" lIns="274320" rIns="274320" tIns="274320" bIns="274320"/>
+          <a:lstStyle/>
+          <a:p>
+            <a:pPr algn="ctr">
+              <a:spcAft>
+                <a:spcPts val="1200"/>
+              </a:spcAft>
+              <a:defRPr sz="2400" b="1">
+                <a:solidFill>
+                  <a:srgbClr val="1E293B"/>
+                </a:solidFill>
+                <a:latin typeface="Trebuchet MS"/>
+              </a:defRPr>
+            </a:pPr>
+            <a:r>
+              <a:t>Execution Results &amp; Complexity Limits</a:t>
+            </a:r>
+          </a:p>
+          <a:p>
+            <a:pPr>
+              <a:spcAft>
+                <a:spcPts val="600"/>
+              </a:spcAft>
+              <a:defRPr sz="1500" b="1">
+                <a:solidFill>
+                  <a:srgbClr val="0F172A"/>
+                </a:solidFill>
+                <a:latin typeface="Calibri"/>
+              </a:defRPr>
+            </a:pPr>
+            <a:r>
+              <a:t>Mall Customers (200 pts): 234.5 ms</a:t>
+            </a:r>
+          </a:p>
+          <a:p>
+            <a:pPr>
+              <a:spcAft>
+                <a:spcPts val="600"/>
+              </a:spcAft>
+              <a:defRPr sz="1500" b="1">
+                <a:solidFill>
+                  <a:srgbClr val="0F172A"/>
+                </a:solidFill>
+                <a:latin typeface="Calibri"/>
+              </a:defRPr>
+            </a:pPr>
+            <a:r>
+              <a:t>Covertype K=7 (581K pts): 33,950.7 ms</a:t>
+            </a:r>
+          </a:p>
+          <a:p>
+            <a:pPr>
+              <a:spcAft>
+                <a:spcPts val="600"/>
+              </a:spcAft>
+              <a:defRPr sz="1500" b="1">
+                <a:solidFill>
+                  <a:srgbClr val="0F172A"/>
+                </a:solidFill>
+                <a:latin typeface="Calibri"/>
+              </a:defRPr>
+            </a:pPr>
+            <a:r>
+              <a:t>Covertype K=50 (581K pts): 45,524.7 ms</a:t>
+            </a:r>
+          </a:p>
+          <a:p>
+            <a:pPr>
+              <a:spcAft>
+                <a:spcPts val="600"/>
+              </a:spcAft>
+              <a:defRPr sz="1500" b="1">
+                <a:solidFill>
+                  <a:srgbClr val="0F172A"/>
+                </a:solidFill>
+                <a:latin typeface="Calibri"/>
+              </a:defRPr>
+            </a:pPr>
+            <a:r>
+              <a:t>KDD Cup 10% (494K pts): 21,798.9 ms</a:t>
+            </a:r>
+          </a:p>
+          <a:p>
+            <a:pPr>
+              <a:spcBef>
+                <a:spcPts val="1200"/>
+              </a:spcBef>
+              <a:spcAft>
+                <a:spcPts val="800"/>
+              </a:spcAft>
+              <a:defRPr sz="1800" b="1">
+                <a:solidFill>
+                  <a:srgbClr val="06B6D4"/>
+                </a:solidFill>
+                <a:latin typeface="Trebuchet MS"/>
+              </a:defRPr>
+            </a:pPr>
+            <a:r>
+              <a:t>The Final Dataset (KDD Cup Full - 4.89M pts):</a:t>
+            </a:r>
+          </a:p>
+          <a:p>
+            <a:pPr>
+              <a:spcAft>
+                <a:spcPts val="600"/>
+              </a:spcAft>
+              <a:defRPr sz="1400" b="1">
+                <a:solidFill>
+                  <a:srgbClr val="EF4444"/>
+                </a:solidFill>
+                <a:latin typeface="Calibri"/>
+              </a:defRPr>
+            </a:pPr>
+            <a:r>
+              <a:t>STATUS: Could not be completed (Colab dataset download failed).</a:t>
+            </a:r>
+          </a:p>
+          <a:p>
+            <a:pPr>
+              <a:defRPr sz="1300">
+                <a:solidFill>
+                  <a:srgbClr val="0F172A"/>
+                </a:solidFill>
+                <a:latin typeface="Calibri"/>
+              </a:defRPr>
+            </a:pPr>
+            <a:r>
+              <a:t>Theoretical Extrapolation: An N×N matrix for 4.89 million points requires nearly 24 TRILLION distance computations. Even if downloaded, the T4 GPU would likely have encountered an Out-of-Memory (OOM) error or exceeded Colab's session time limits.</a:t>
+            </a:r>
+          </a:p>
+        </p:txBody>
+      </p:sp>
+      <p:sp>
+        <p:nvSpPr>
+          <p:cNvPr id="6" name="TextBox 5"/>
+          <p:cNvSpPr txBox="1"/>
+          <p:nvPr/>
+        </p:nvSpPr>
+        <p:spPr>
+          <a:xfrm>
+            <a:off x="731520" y="6400800"/>
+            <a:ext cx="10698480" cy="274320"/>
+          </a:xfrm>
+          <a:prstGeom prst="rect">
+            <a:avLst/>
+          </a:prstGeom>
+          <a:noFill/>
+        </p:spPr>
+        <p:txBody>
+          <a:bodyPr wrap="square" lIns="0" tIns="0" rIns="0" bIns="0">
+            <a:spAutoFit/>
+          </a:bodyPr>
+          <a:lstStyle/>
+          <a:p>
+            <a:pPr>
+              <a:defRPr sz="1100">
+                <a:solidFill>
+                  <a:srgbClr val="64748B"/>
+                </a:solidFill>
+                <a:latin typeface="Calibri"/>
+              </a:defRPr>
+            </a:pPr>
+            <a:r>
+              <a:t>AMD Ryzen 7 7840HS &amp; Radeon 780M Benchmarking Suite | Page 11 of 12</a:t>
+            </a:r>
+          </a:p>
+        </p:txBody>
+      </p:sp>
+    </p:spTree>
+  </p:cSld>
+  <p:clrMapOvr>
+    <a:masterClrMapping/>
+  </p:clrMapOvr>
+</p:sld>
+</file>
+
+<file path=ppt/slides/slide12.xml><?xml version="1.0" encoding="utf-8"?>
 <p:sld xmlns:a="http://schemas.openxmlformats.org/drawingml/2006/main" xmlns:p="http://schemas.openxmlformats.org/presentationml/2006/main" xmlns:r="http://schemas.openxmlformats.org/officeDocument/2006/relationships">
   <p:cSld>
     <p:bg>
@@ -5248,7 +5691,7 @@
               </a:defRPr>
             </a:pPr>
             <a:r>
-              <a:t>AMD Ryzen 7 7840HS &amp; Radeon 780M Benchmarking Suite | Page 11 of 11</a:t>
+              <a:t>AMD Ryzen 7 7840HS &amp; Radeon 780M Benchmarking Suite | Page 12 of 12</a:t>
             </a:r>
           </a:p>
         </p:txBody>
@@ -5642,7 +6085,7 @@
               </a:defRPr>
             </a:pPr>
             <a:r>
-              <a:t>AMD Ryzen 7 7840HS &amp; Radeon 780M Benchmarking Suite | Page 2 of 11</a:t>
+              <a:t>AMD Ryzen 7 7840HS &amp; Radeon 780M Benchmarking Suite | Page 2 of 12</a:t>
             </a:r>
           </a:p>
         </p:txBody>
@@ -6052,7 +6495,7 @@
               </a:defRPr>
             </a:pPr>
             <a:r>
-              <a:t>AMD Ryzen 7 7840HS &amp; Radeon 780M Benchmarking Suite | Page 3 of 11</a:t>
+              <a:t>AMD Ryzen 7 7840HS &amp; Radeon 780M Benchmarking Suite | Page 3 of 12</a:t>
             </a:r>
           </a:p>
         </p:txBody>
@@ -6522,7 +6965,7 @@
               </a:defRPr>
             </a:pPr>
             <a:r>
-              <a:t>AMD Ryzen 7 7840HS &amp; Radeon 780M Benchmarking Suite | Page 4 of 11</a:t>
+              <a:t>AMD Ryzen 7 7840HS &amp; Radeon 780M Benchmarking Suite | Page 4 of 12</a:t>
             </a:r>
           </a:p>
         </p:txBody>
@@ -6953,7 +7396,7 @@
               </a:defRPr>
             </a:pPr>
             <a:r>
-              <a:t>AMD Ryzen 7 7840HS &amp; Radeon 780M Benchmarking Suite | Page 5 of 11</a:t>
+              <a:t>AMD Ryzen 7 7840HS &amp; Radeon 780M Benchmarking Suite | Page 5 of 12</a:t>
             </a:r>
           </a:p>
         </p:txBody>
@@ -7229,7 +7672,7 @@
               </a:defRPr>
             </a:pPr>
             <a:r>
-              <a:t>AMD Ryzen 7 7840HS &amp; Radeon 780M Benchmarking Suite | Page 6 of 11</a:t>
+              <a:t>AMD Ryzen 7 7840HS &amp; Radeon 780M Benchmarking Suite | Page 6 of 12</a:t>
             </a:r>
           </a:p>
         </p:txBody>
@@ -8665,7 +9108,7 @@
               </a:defRPr>
             </a:pPr>
             <a:r>
-              <a:t>AMD Ryzen 7 7840HS &amp; Radeon 780M Benchmarking Suite | Page 7 of 11</a:t>
+              <a:t>AMD Ryzen 7 7840HS &amp; Radeon 780M Benchmarking Suite | Page 7 of 12</a:t>
             </a:r>
           </a:p>
         </p:txBody>
@@ -8835,7 +9278,7 @@
               </a:defRPr>
             </a:pPr>
             <a:r>
-              <a:t>AMD Ryzen 7 7840HS &amp; Radeon 780M Benchmarking Suite | Page 8 of 11</a:t>
+              <a:t>AMD Ryzen 7 7840HS &amp; Radeon 780M Benchmarking Suite | Page 8 of 12</a:t>
             </a:r>
           </a:p>
         </p:txBody>
@@ -10271,7 +10714,7 @@
               </a:defRPr>
             </a:pPr>
             <a:r>
-              <a:t>AMD Ryzen 7 7840HS &amp; Radeon 780M Benchmarking Suite | Page 9 of 11</a:t>
+              <a:t>AMD Ryzen 7 7840HS &amp; Radeon 780M Benchmarking Suite | Page 9 of 12</a:t>
             </a:r>
           </a:p>
         </p:txBody>

</xml_diff>